<commit_message>
Add glossary appendix spelling out every abbreviation
Append a two-slide glossary that gives the full name and a brief
explanation for every abbreviation used in the deck — TRL, POS,
CPOS, rNPV, DCF, WACC, EV, EBITDA, P/E, TAM/SAM/SOM, CAGR, FDA,
510(k) and others — grouped into valuation/finance terms and
market/science/deal terms. Deck is now 43 slides.

https://claude.ai/code/session_01X1i5WfgWxXvbnFetYsncGp
</commit_message>
<xml_diff>
--- a/docs/training/Valuing_Deep_Tech_Ventures_DTL_Training.pptx
+++ b/docs/training/Valuing_Deep_Tech_Ventures_DTL_Training.pptx
@@ -46,6 +46,8 @@
     <p:sldId id="294" r:id="rId46"/>
     <p:sldId id="295" r:id="rId47"/>
     <p:sldId id="296" r:id="rId48"/>
+    <p:sldId id="297" r:id="rId49"/>
+    <p:sldId id="298" r:id="rId50"/>
   </p:sldIdLst>
   <p:sldSz cx="12191695" cy="6858000" type="screen4x3"/>
   <p:notesSz cx="6858000" cy="9144000"/>
@@ -2993,6 +2995,146 @@
           <a:p>
             <a:r>
               <a:t>Restate the four takeaways; point to the reading list.</a:t>
+            </a:r>
+          </a:p>
+        </p:txBody>
+      </p:sp>
+      <p:sp>
+        <p:nvSpPr>
+          <p:cNvPr id="4" name="Slide Number Placeholder 3"/>
+          <p:cNvSpPr>
+            <a:spLocks noGrp="1"/>
+          </p:cNvSpPr>
+          <p:nvPr>
+            <p:ph type="sldNum" idx="5" sz="quarter"/>
+          </p:nvPr>
+        </p:nvSpPr>
+        <p:spPr/>
+      </p:sp>
+    </p:spTree>
+  </p:cSld>
+  <p:clrMapOvr>
+    <a:masterClrMapping/>
+  </p:clrMapOvr>
+</p:notes>
+</file>
+
+<file path=ppt/notesSlides/notesSlide42.xml><?xml version="1.0" encoding="utf-8"?>
+<p:notes xmlns:a="http://schemas.openxmlformats.org/drawingml/2006/main" xmlns:p="http://schemas.openxmlformats.org/presentationml/2006/main" xmlns:r="http://schemas.openxmlformats.org/officeDocument/2006/relationships">
+  <p:cSld>
+    <p:spTree>
+      <p:nvGrpSpPr>
+        <p:cNvPr id="1" name=""/>
+        <p:cNvGrpSpPr/>
+        <p:nvPr/>
+      </p:nvGrpSpPr>
+      <p:grpSpPr>
+        <a:xfrm>
+          <a:off x="0" y="0"/>
+          <a:ext cx="0" cy="0"/>
+          <a:chOff x="0" y="0"/>
+          <a:chExt cx="0" cy="0"/>
+        </a:xfrm>
+      </p:grpSpPr>
+      <p:sp>
+        <p:nvSpPr>
+          <p:cNvPr id="2" name="Slide Image Placeholder 1"/>
+          <p:cNvSpPr>
+            <a:spLocks noGrp="1"/>
+          </p:cNvSpPr>
+          <p:nvPr>
+            <p:ph type="sldImg" idx="2"/>
+          </p:nvPr>
+        </p:nvSpPr>
+        <p:spPr/>
+      </p:sp>
+      <p:sp>
+        <p:nvSpPr>
+          <p:cNvPr id="3" name="Notes Placeholder 2"/>
+          <p:cNvSpPr>
+            <a:spLocks noGrp="1"/>
+          </p:cNvSpPr>
+          <p:nvPr>
+            <p:ph type="body" idx="3" sz="quarter"/>
+          </p:nvPr>
+        </p:nvSpPr>
+        <p:spPr/>
+        <p:txBody>
+          <a:bodyPr/>
+          <a:lstStyle/>
+          <a:p>
+            <a:r>
+              <a:t>Glossary appendix — every abbreviation used in the deck spelled out in full. Refer participants here whenever a term is unclear.</a:t>
+            </a:r>
+          </a:p>
+        </p:txBody>
+      </p:sp>
+      <p:sp>
+        <p:nvSpPr>
+          <p:cNvPr id="4" name="Slide Number Placeholder 3"/>
+          <p:cNvSpPr>
+            <a:spLocks noGrp="1"/>
+          </p:cNvSpPr>
+          <p:nvPr>
+            <p:ph type="sldNum" idx="5" sz="quarter"/>
+          </p:nvPr>
+        </p:nvSpPr>
+        <p:spPr/>
+      </p:sp>
+    </p:spTree>
+  </p:cSld>
+  <p:clrMapOvr>
+    <a:masterClrMapping/>
+  </p:clrMapOvr>
+</p:notes>
+</file>
+
+<file path=ppt/notesSlides/notesSlide43.xml><?xml version="1.0" encoding="utf-8"?>
+<p:notes xmlns:a="http://schemas.openxmlformats.org/drawingml/2006/main" xmlns:p="http://schemas.openxmlformats.org/presentationml/2006/main" xmlns:r="http://schemas.openxmlformats.org/officeDocument/2006/relationships">
+  <p:cSld>
+    <p:spTree>
+      <p:nvGrpSpPr>
+        <p:cNvPr id="1" name=""/>
+        <p:cNvGrpSpPr/>
+        <p:nvPr/>
+      </p:nvGrpSpPr>
+      <p:grpSpPr>
+        <a:xfrm>
+          <a:off x="0" y="0"/>
+          <a:ext cx="0" cy="0"/>
+          <a:chOff x="0" y="0"/>
+          <a:chExt cx="0" cy="0"/>
+        </a:xfrm>
+      </p:grpSpPr>
+      <p:sp>
+        <p:nvSpPr>
+          <p:cNvPr id="2" name="Slide Image Placeholder 1"/>
+          <p:cNvSpPr>
+            <a:spLocks noGrp="1"/>
+          </p:cNvSpPr>
+          <p:nvPr>
+            <p:ph type="sldImg" idx="2"/>
+          </p:nvPr>
+        </p:nvSpPr>
+        <p:spPr/>
+      </p:sp>
+      <p:sp>
+        <p:nvSpPr>
+          <p:cNvPr id="3" name="Notes Placeholder 2"/>
+          <p:cNvSpPr>
+            <a:spLocks noGrp="1"/>
+          </p:cNvSpPr>
+          <p:nvPr>
+            <p:ph type="body" idx="3" sz="quarter"/>
+          </p:nvPr>
+        </p:nvSpPr>
+        <p:spPr/>
+        <p:txBody>
+          <a:bodyPr/>
+          <a:lstStyle/>
+          <a:p>
+            <a:r>
+              <a:t>Glossary appendix — every abbreviation used in the deck spelled out in full. Refer participants here whenever a term is unclear.</a:t>
             </a:r>
           </a:p>
         </p:txBody>
@@ -40876,6 +41018,2013 @@
                 <a:latin typeface="Georgia"/>
               </a:rPr>
               <a:t>41</a:t>
+            </a:r>
+          </a:p>
+        </p:txBody>
+      </p:sp>
+    </p:spTree>
+  </p:cSld>
+  <p:clrMapOvr>
+    <a:masterClrMapping/>
+  </p:clrMapOvr>
+</p:sld>
+</file>
+
+<file path=ppt/slides/slide42.xml><?xml version="1.0" encoding="utf-8"?>
+<p:sld xmlns:a="http://schemas.openxmlformats.org/drawingml/2006/main" xmlns:p="http://schemas.openxmlformats.org/presentationml/2006/main" xmlns:r="http://schemas.openxmlformats.org/officeDocument/2006/relationships">
+  <p:cSld>
+    <p:spTree>
+      <p:nvGrpSpPr>
+        <p:cNvPr id="1" name=""/>
+        <p:cNvGrpSpPr/>
+        <p:nvPr/>
+      </p:nvGrpSpPr>
+      <p:grpSpPr/>
+      <p:sp>
+        <p:nvSpPr>
+          <p:cNvPr id="2" name="Rectangle 1"/>
+          <p:cNvSpPr/>
+          <p:nvPr/>
+        </p:nvSpPr>
+        <p:spPr>
+          <a:xfrm>
+            <a:off x="0" y="0"/>
+            <a:ext cx="12191695" cy="969264"/>
+          </a:xfrm>
+          <a:prstGeom prst="rect">
+            <a:avLst/>
+          </a:prstGeom>
+          <a:solidFill>
+            <a:srgbClr val="0F2A4A"/>
+          </a:solidFill>
+          <a:ln>
+            <a:noFill/>
+          </a:ln>
+          <a:effectLst/>
+        </p:spPr>
+        <p:style>
+          <a:lnRef idx="1">
+            <a:schemeClr val="accent1"/>
+          </a:lnRef>
+          <a:fillRef idx="3">
+            <a:schemeClr val="accent1"/>
+          </a:fillRef>
+          <a:effectRef idx="2">
+            <a:schemeClr val="accent1"/>
+          </a:effectRef>
+          <a:fontRef idx="minor">
+            <a:schemeClr val="lt1"/>
+          </a:fontRef>
+        </p:style>
+        <p:txBody>
+          <a:bodyPr rtlCol="0" anchor="ctr"/>
+          <a:lstStyle/>
+          <a:p>
+            <a:pPr algn="ctr"/>
+          </a:p>
+        </p:txBody>
+      </p:sp>
+      <p:sp>
+        <p:nvSpPr>
+          <p:cNvPr id="3" name="Rectangle 2"/>
+          <p:cNvSpPr/>
+          <p:nvPr/>
+        </p:nvSpPr>
+        <p:spPr>
+          <a:xfrm>
+            <a:off x="0" y="969264"/>
+            <a:ext cx="12191695" cy="50292"/>
+          </a:xfrm>
+          <a:prstGeom prst="rect">
+            <a:avLst/>
+          </a:prstGeom>
+          <a:solidFill>
+            <a:srgbClr val="E08E2B"/>
+          </a:solidFill>
+          <a:ln>
+            <a:noFill/>
+          </a:ln>
+          <a:effectLst/>
+        </p:spPr>
+        <p:style>
+          <a:lnRef idx="1">
+            <a:schemeClr val="accent1"/>
+          </a:lnRef>
+          <a:fillRef idx="3">
+            <a:schemeClr val="accent1"/>
+          </a:fillRef>
+          <a:effectRef idx="2">
+            <a:schemeClr val="accent1"/>
+          </a:effectRef>
+          <a:fontRef idx="minor">
+            <a:schemeClr val="lt1"/>
+          </a:fontRef>
+        </p:style>
+        <p:txBody>
+          <a:bodyPr rtlCol="0" anchor="ctr"/>
+          <a:lstStyle/>
+          <a:p>
+            <a:pPr algn="ctr"/>
+          </a:p>
+        </p:txBody>
+      </p:sp>
+      <p:sp>
+        <p:nvSpPr>
+          <p:cNvPr id="4" name="TextBox 3"/>
+          <p:cNvSpPr txBox="1"/>
+          <p:nvPr/>
+        </p:nvSpPr>
+        <p:spPr>
+          <a:xfrm>
+            <a:off x="502920" y="118872"/>
+            <a:ext cx="10972800" cy="292608"/>
+          </a:xfrm>
+          <a:prstGeom prst="rect">
+            <a:avLst/>
+          </a:prstGeom>
+          <a:noFill/>
+        </p:spPr>
+        <p:txBody>
+          <a:bodyPr wrap="square" lIns="18288" rIns="18288" tIns="18288" bIns="18288" anchor="t">
+            <a:spAutoFit/>
+          </a:bodyPr>
+          <a:lstStyle/>
+          <a:p>
+            <a:pPr algn="l">
+              <a:spcBef>
+                <a:spcPts val="0"/>
+              </a:spcBef>
+              <a:spcAft>
+                <a:spcPts val="0"/>
+              </a:spcAft>
+            </a:pPr>
+            <a:r>
+              <a:rPr sz="1200" b="1" i="0">
+                <a:solidFill>
+                  <a:srgbClr val="E08E2B"/>
+                </a:solidFill>
+                <a:latin typeface="Calibri"/>
+              </a:rPr>
+              <a:t>APPENDIX  ·  GLOSSARY</a:t>
+            </a:r>
+          </a:p>
+        </p:txBody>
+      </p:sp>
+      <p:sp>
+        <p:nvSpPr>
+          <p:cNvPr id="5" name="TextBox 4"/>
+          <p:cNvSpPr txBox="1"/>
+          <p:nvPr/>
+        </p:nvSpPr>
+        <p:spPr>
+          <a:xfrm>
+            <a:off x="502920" y="365760"/>
+            <a:ext cx="11201400" cy="585216"/>
+          </a:xfrm>
+          <a:prstGeom prst="rect">
+            <a:avLst/>
+          </a:prstGeom>
+          <a:noFill/>
+        </p:spPr>
+        <p:txBody>
+          <a:bodyPr wrap="square" lIns="18288" rIns="18288" tIns="18288" bIns="18288" anchor="t">
+            <a:spAutoFit/>
+          </a:bodyPr>
+          <a:lstStyle/>
+          <a:p>
+            <a:pPr algn="l">
+              <a:spcBef>
+                <a:spcPts val="0"/>
+              </a:spcBef>
+              <a:spcAft>
+                <a:spcPts val="0"/>
+              </a:spcAft>
+            </a:pPr>
+            <a:r>
+              <a:rPr sz="2500" b="1" i="0">
+                <a:solidFill>
+                  <a:srgbClr val="FFFFFF"/>
+                </a:solidFill>
+                <a:latin typeface="Georgia"/>
+              </a:rPr>
+              <a:t>Abbreviations in full — valuation &amp; finance</a:t>
+            </a:r>
+          </a:p>
+        </p:txBody>
+      </p:sp>
+      <p:sp>
+        <p:nvSpPr>
+          <p:cNvPr id="6" name="TextBox 5"/>
+          <p:cNvSpPr txBox="1"/>
+          <p:nvPr/>
+        </p:nvSpPr>
+        <p:spPr>
+          <a:xfrm>
+            <a:off x="566928" y="1133856"/>
+            <a:ext cx="11064240" cy="457200"/>
+          </a:xfrm>
+          <a:prstGeom prst="rect">
+            <a:avLst/>
+          </a:prstGeom>
+          <a:noFill/>
+        </p:spPr>
+        <p:txBody>
+          <a:bodyPr wrap="square" lIns="18288" rIns="18288" tIns="18288" bIns="18288" anchor="t">
+            <a:spAutoFit/>
+          </a:bodyPr>
+          <a:lstStyle/>
+          <a:p>
+            <a:pPr algn="l">
+              <a:spcBef>
+                <a:spcPts val="0"/>
+              </a:spcBef>
+              <a:spcAft>
+                <a:spcPts val="0"/>
+              </a:spcAft>
+            </a:pPr>
+            <a:r>
+              <a:rPr sz="1400" b="0" i="1">
+                <a:solidFill>
+                  <a:srgbClr val="4C5D6D"/>
+                </a:solidFill>
+                <a:latin typeface="Calibri"/>
+              </a:rPr>
+              <a:t>Every abbreviation used in this deck, spelled out and briefly explained.</a:t>
+            </a:r>
+          </a:p>
+        </p:txBody>
+      </p:sp>
+      <p:sp>
+        <p:nvSpPr>
+          <p:cNvPr id="7" name="Rectangle 6"/>
+          <p:cNvSpPr/>
+          <p:nvPr/>
+        </p:nvSpPr>
+        <p:spPr>
+          <a:xfrm>
+            <a:off x="603504" y="1719072"/>
+            <a:ext cx="82296" cy="4160520"/>
+          </a:xfrm>
+          <a:prstGeom prst="rect">
+            <a:avLst/>
+          </a:prstGeom>
+          <a:solidFill>
+            <a:srgbClr val="E08E2B"/>
+          </a:solidFill>
+          <a:ln>
+            <a:noFill/>
+          </a:ln>
+          <a:effectLst/>
+        </p:spPr>
+        <p:style>
+          <a:lnRef idx="1">
+            <a:schemeClr val="accent1"/>
+          </a:lnRef>
+          <a:fillRef idx="3">
+            <a:schemeClr val="accent1"/>
+          </a:fillRef>
+          <a:effectRef idx="2">
+            <a:schemeClr val="accent1"/>
+          </a:effectRef>
+          <a:fontRef idx="minor">
+            <a:schemeClr val="lt1"/>
+          </a:fontRef>
+        </p:style>
+        <p:txBody>
+          <a:bodyPr rtlCol="0" anchor="ctr"/>
+          <a:lstStyle/>
+          <a:p>
+            <a:pPr algn="ctr"/>
+          </a:p>
+        </p:txBody>
+      </p:sp>
+      <p:sp>
+        <p:nvSpPr>
+          <p:cNvPr id="8" name="TextBox 7"/>
+          <p:cNvSpPr txBox="1"/>
+          <p:nvPr/>
+        </p:nvSpPr>
+        <p:spPr>
+          <a:xfrm>
+            <a:off x="841248" y="1645920"/>
+            <a:ext cx="5138928" cy="4526280"/>
+          </a:xfrm>
+          <a:prstGeom prst="rect">
+            <a:avLst/>
+          </a:prstGeom>
+          <a:noFill/>
+        </p:spPr>
+        <p:txBody>
+          <a:bodyPr wrap="square">
+            <a:spAutoFit/>
+          </a:bodyPr>
+          <a:lstStyle/>
+          <a:p>
+            <a:pPr>
+              <a:spcBef>
+                <a:spcPts val="0"/>
+              </a:spcBef>
+            </a:pPr>
+            <a:r>
+              <a:rPr sz="1500" b="1">
+                <a:solidFill>
+                  <a:srgbClr val="E08E2B"/>
+                </a:solidFill>
+                <a:latin typeface="Consolas"/>
+              </a:rPr>
+              <a:t>TRL</a:t>
+            </a:r>
+            <a:r>
+              <a:rPr sz="1450" b="1">
+                <a:solidFill>
+                  <a:srgbClr val="0F2A4A"/>
+                </a:solidFill>
+                <a:latin typeface="Georgia"/>
+              </a:rPr>
+              <a:t>   Technology Readiness Level</a:t>
+            </a:r>
+          </a:p>
+          <a:p>
+            <a:pPr>
+              <a:spcBef>
+                <a:spcPts val="100"/>
+              </a:spcBef>
+            </a:pPr>
+            <a:r>
+              <a:rPr sz="1300">
+                <a:solidFill>
+                  <a:srgbClr val="4C5D6D"/>
+                </a:solidFill>
+                <a:latin typeface="Calibri"/>
+              </a:rPr>
+              <a:t>Maturity scale from 1 (basic idea) to 9 (proven in use).</a:t>
+            </a:r>
+          </a:p>
+          <a:p>
+            <a:pPr>
+              <a:spcBef>
+                <a:spcPts val="1100"/>
+              </a:spcBef>
+            </a:pPr>
+            <a:r>
+              <a:rPr sz="1500" b="1">
+                <a:solidFill>
+                  <a:srgbClr val="E08E2B"/>
+                </a:solidFill>
+                <a:latin typeface="Consolas"/>
+              </a:rPr>
+              <a:t>POS</a:t>
+            </a:r>
+            <a:r>
+              <a:rPr sz="1450" b="1">
+                <a:solidFill>
+                  <a:srgbClr val="0F2A4A"/>
+                </a:solidFill>
+                <a:latin typeface="Georgia"/>
+              </a:rPr>
+              <a:t>   Probability of Success</a:t>
+            </a:r>
+          </a:p>
+          <a:p>
+            <a:pPr>
+              <a:spcBef>
+                <a:spcPts val="100"/>
+              </a:spcBef>
+            </a:pPr>
+            <a:r>
+              <a:rPr sz="1300">
+                <a:solidFill>
+                  <a:srgbClr val="4C5D6D"/>
+                </a:solidFill>
+                <a:latin typeface="Calibri"/>
+              </a:rPr>
+              <a:t>The chance that a given milestone is achieved.</a:t>
+            </a:r>
+          </a:p>
+          <a:p>
+            <a:pPr>
+              <a:spcBef>
+                <a:spcPts val="1100"/>
+              </a:spcBef>
+            </a:pPr>
+            <a:r>
+              <a:rPr sz="1500" b="1">
+                <a:solidFill>
+                  <a:srgbClr val="E08E2B"/>
+                </a:solidFill>
+                <a:latin typeface="Consolas"/>
+              </a:rPr>
+              <a:t>CPOS</a:t>
+            </a:r>
+            <a:r>
+              <a:rPr sz="1450" b="1">
+                <a:solidFill>
+                  <a:srgbClr val="0F2A4A"/>
+                </a:solidFill>
+                <a:latin typeface="Georgia"/>
+              </a:rPr>
+              <a:t>   Cumulative Probability of Success</a:t>
+            </a:r>
+          </a:p>
+          <a:p>
+            <a:pPr>
+              <a:spcBef>
+                <a:spcPts val="100"/>
+              </a:spcBef>
+            </a:pPr>
+            <a:r>
+              <a:rPr sz="1300">
+                <a:solidFill>
+                  <a:srgbClr val="4C5D6D"/>
+                </a:solidFill>
+                <a:latin typeface="Calibri"/>
+              </a:rPr>
+              <a:t>Product of every milestone POS up to a given date.</a:t>
+            </a:r>
+          </a:p>
+          <a:p>
+            <a:pPr>
+              <a:spcBef>
+                <a:spcPts val="1100"/>
+              </a:spcBef>
+            </a:pPr>
+            <a:r>
+              <a:rPr sz="1500" b="1">
+                <a:solidFill>
+                  <a:srgbClr val="E08E2B"/>
+                </a:solidFill>
+                <a:latin typeface="Consolas"/>
+              </a:rPr>
+              <a:t>NPV</a:t>
+            </a:r>
+            <a:r>
+              <a:rPr sz="1450" b="1">
+                <a:solidFill>
+                  <a:srgbClr val="0F2A4A"/>
+                </a:solidFill>
+                <a:latin typeface="Georgia"/>
+              </a:rPr>
+              <a:t>   Net Present Value</a:t>
+            </a:r>
+          </a:p>
+          <a:p>
+            <a:pPr>
+              <a:spcBef>
+                <a:spcPts val="100"/>
+              </a:spcBef>
+            </a:pPr>
+            <a:r>
+              <a:rPr sz="1300">
+                <a:solidFill>
+                  <a:srgbClr val="4C5D6D"/>
+                </a:solidFill>
+                <a:latin typeface="Calibri"/>
+              </a:rPr>
+              <a:t>Future cash flows discounted to their value today.</a:t>
+            </a:r>
+          </a:p>
+          <a:p>
+            <a:pPr>
+              <a:spcBef>
+                <a:spcPts val="1100"/>
+              </a:spcBef>
+            </a:pPr>
+            <a:r>
+              <a:rPr sz="1500" b="1">
+                <a:solidFill>
+                  <a:srgbClr val="E08E2B"/>
+                </a:solidFill>
+                <a:latin typeface="Consolas"/>
+              </a:rPr>
+              <a:t>rNPV</a:t>
+            </a:r>
+            <a:r>
+              <a:rPr sz="1450" b="1">
+                <a:solidFill>
+                  <a:srgbClr val="0F2A4A"/>
+                </a:solidFill>
+                <a:latin typeface="Georgia"/>
+              </a:rPr>
+              <a:t>   risk-adjusted Net Present Value</a:t>
+            </a:r>
+          </a:p>
+          <a:p>
+            <a:pPr>
+              <a:spcBef>
+                <a:spcPts val="100"/>
+              </a:spcBef>
+            </a:pPr>
+            <a:r>
+              <a:rPr sz="1300">
+                <a:solidFill>
+                  <a:srgbClr val="4C5D6D"/>
+                </a:solidFill>
+                <a:latin typeface="Calibri"/>
+              </a:rPr>
+              <a:t>NPV weighted by CPOS; also called eNPV (expected NPV).</a:t>
+            </a:r>
+          </a:p>
+          <a:p>
+            <a:pPr>
+              <a:spcBef>
+                <a:spcPts val="1100"/>
+              </a:spcBef>
+            </a:pPr>
+            <a:r>
+              <a:rPr sz="1500" b="1">
+                <a:solidFill>
+                  <a:srgbClr val="E08E2B"/>
+                </a:solidFill>
+                <a:latin typeface="Consolas"/>
+              </a:rPr>
+              <a:t>DCF</a:t>
+            </a:r>
+            <a:r>
+              <a:rPr sz="1450" b="1">
+                <a:solidFill>
+                  <a:srgbClr val="0F2A4A"/>
+                </a:solidFill>
+                <a:latin typeface="Georgia"/>
+              </a:rPr>
+              <a:t>   Discounted Cash Flow</a:t>
+            </a:r>
+          </a:p>
+          <a:p>
+            <a:pPr>
+              <a:spcBef>
+                <a:spcPts val="100"/>
+              </a:spcBef>
+            </a:pPr>
+            <a:r>
+              <a:rPr sz="1300">
+                <a:solidFill>
+                  <a:srgbClr val="4C5D6D"/>
+                </a:solidFill>
+                <a:latin typeface="Calibri"/>
+              </a:rPr>
+              <a:t>Valuation by discounting projected future cash flows.</a:t>
+            </a:r>
+          </a:p>
+          <a:p>
+            <a:pPr>
+              <a:spcBef>
+                <a:spcPts val="1100"/>
+              </a:spcBef>
+            </a:pPr>
+            <a:r>
+              <a:rPr sz="1500" b="1">
+                <a:solidFill>
+                  <a:srgbClr val="E08E2B"/>
+                </a:solidFill>
+                <a:latin typeface="Consolas"/>
+              </a:rPr>
+              <a:t>CF</a:t>
+            </a:r>
+            <a:r>
+              <a:rPr sz="1450" b="1">
+                <a:solidFill>
+                  <a:srgbClr val="0F2A4A"/>
+                </a:solidFill>
+                <a:latin typeface="Georgia"/>
+              </a:rPr>
+              <a:t>   Cash Flow</a:t>
+            </a:r>
+          </a:p>
+          <a:p>
+            <a:pPr>
+              <a:spcBef>
+                <a:spcPts val="100"/>
+              </a:spcBef>
+            </a:pPr>
+            <a:r>
+              <a:rPr sz="1300">
+                <a:solidFill>
+                  <a:srgbClr val="4C5D6D"/>
+                </a:solidFill>
+                <a:latin typeface="Calibri"/>
+              </a:rPr>
+              <a:t>CF in year t — the cash, or exit value, expected then.</a:t>
+            </a:r>
+          </a:p>
+        </p:txBody>
+      </p:sp>
+      <p:sp>
+        <p:nvSpPr>
+          <p:cNvPr id="9" name="Rectangle 8"/>
+          <p:cNvSpPr/>
+          <p:nvPr/>
+        </p:nvSpPr>
+        <p:spPr>
+          <a:xfrm>
+            <a:off x="6254496" y="1719072"/>
+            <a:ext cx="82296" cy="4160520"/>
+          </a:xfrm>
+          <a:prstGeom prst="rect">
+            <a:avLst/>
+          </a:prstGeom>
+          <a:solidFill>
+            <a:srgbClr val="E08E2B"/>
+          </a:solidFill>
+          <a:ln>
+            <a:noFill/>
+          </a:ln>
+          <a:effectLst/>
+        </p:spPr>
+        <p:style>
+          <a:lnRef idx="1">
+            <a:schemeClr val="accent1"/>
+          </a:lnRef>
+          <a:fillRef idx="3">
+            <a:schemeClr val="accent1"/>
+          </a:fillRef>
+          <a:effectRef idx="2">
+            <a:schemeClr val="accent1"/>
+          </a:effectRef>
+          <a:fontRef idx="minor">
+            <a:schemeClr val="lt1"/>
+          </a:fontRef>
+        </p:style>
+        <p:txBody>
+          <a:bodyPr rtlCol="0" anchor="ctr"/>
+          <a:lstStyle/>
+          <a:p>
+            <a:pPr algn="ctr"/>
+          </a:p>
+        </p:txBody>
+      </p:sp>
+      <p:sp>
+        <p:nvSpPr>
+          <p:cNvPr id="10" name="TextBox 9"/>
+          <p:cNvSpPr txBox="1"/>
+          <p:nvPr/>
+        </p:nvSpPr>
+        <p:spPr>
+          <a:xfrm>
+            <a:off x="6492240" y="1645920"/>
+            <a:ext cx="5138928" cy="4526280"/>
+          </a:xfrm>
+          <a:prstGeom prst="rect">
+            <a:avLst/>
+          </a:prstGeom>
+          <a:noFill/>
+        </p:spPr>
+        <p:txBody>
+          <a:bodyPr wrap="square">
+            <a:spAutoFit/>
+          </a:bodyPr>
+          <a:lstStyle/>
+          <a:p>
+            <a:pPr>
+              <a:spcBef>
+                <a:spcPts val="0"/>
+              </a:spcBef>
+            </a:pPr>
+            <a:r>
+              <a:rPr sz="1500" b="1">
+                <a:solidFill>
+                  <a:srgbClr val="E08E2B"/>
+                </a:solidFill>
+                <a:latin typeface="Consolas"/>
+              </a:rPr>
+              <a:t>r</a:t>
+            </a:r>
+            <a:r>
+              <a:rPr sz="1450" b="1">
+                <a:solidFill>
+                  <a:srgbClr val="0F2A4A"/>
+                </a:solidFill>
+                <a:latin typeface="Georgia"/>
+              </a:rPr>
+              <a:t>   Discount rate</a:t>
+            </a:r>
+          </a:p>
+          <a:p>
+            <a:pPr>
+              <a:spcBef>
+                <a:spcPts val="100"/>
+              </a:spcBef>
+            </a:pPr>
+            <a:r>
+              <a:rPr sz="1300">
+                <a:solidFill>
+                  <a:srgbClr val="4C5D6D"/>
+                </a:solidFill>
+                <a:latin typeface="Calibri"/>
+              </a:rPr>
+              <a:t>Venture cost of capital — typically 15–40% early-stage.</a:t>
+            </a:r>
+          </a:p>
+          <a:p>
+            <a:pPr>
+              <a:spcBef>
+                <a:spcPts val="1100"/>
+              </a:spcBef>
+            </a:pPr>
+            <a:r>
+              <a:rPr sz="1500" b="1">
+                <a:solidFill>
+                  <a:srgbClr val="E08E2B"/>
+                </a:solidFill>
+                <a:latin typeface="Consolas"/>
+              </a:rPr>
+              <a:t>WACC</a:t>
+            </a:r>
+            <a:r>
+              <a:rPr sz="1450" b="1">
+                <a:solidFill>
+                  <a:srgbClr val="0F2A4A"/>
+                </a:solidFill>
+                <a:latin typeface="Georgia"/>
+              </a:rPr>
+              <a:t>   Weighted Average Cost of Capital</a:t>
+            </a:r>
+          </a:p>
+          <a:p>
+            <a:pPr>
+              <a:spcBef>
+                <a:spcPts val="100"/>
+              </a:spcBef>
+            </a:pPr>
+            <a:r>
+              <a:rPr sz="1300">
+                <a:solidFill>
+                  <a:srgbClr val="4C5D6D"/>
+                </a:solidFill>
+                <a:latin typeface="Calibri"/>
+              </a:rPr>
+              <a:t>Blended cost of equity and debt used to discount cash flows.</a:t>
+            </a:r>
+          </a:p>
+          <a:p>
+            <a:pPr>
+              <a:spcBef>
+                <a:spcPts val="1100"/>
+              </a:spcBef>
+            </a:pPr>
+            <a:r>
+              <a:rPr sz="1500" b="1">
+                <a:solidFill>
+                  <a:srgbClr val="E08E2B"/>
+                </a:solidFill>
+                <a:latin typeface="Consolas"/>
+              </a:rPr>
+              <a:t>EV</a:t>
+            </a:r>
+            <a:r>
+              <a:rPr sz="1450" b="1">
+                <a:solidFill>
+                  <a:srgbClr val="0F2A4A"/>
+                </a:solidFill>
+                <a:latin typeface="Georgia"/>
+              </a:rPr>
+              <a:t>   Enterprise Value</a:t>
+            </a:r>
+          </a:p>
+          <a:p>
+            <a:pPr>
+              <a:spcBef>
+                <a:spcPts val="100"/>
+              </a:spcBef>
+            </a:pPr>
+            <a:r>
+              <a:rPr sz="1300">
+                <a:solidFill>
+                  <a:srgbClr val="4C5D6D"/>
+                </a:solidFill>
+                <a:latin typeface="Calibri"/>
+              </a:rPr>
+              <a:t>The value of the whole business — debt plus equity.</a:t>
+            </a:r>
+          </a:p>
+          <a:p>
+            <a:pPr>
+              <a:spcBef>
+                <a:spcPts val="1100"/>
+              </a:spcBef>
+            </a:pPr>
+            <a:r>
+              <a:rPr sz="1500" b="1">
+                <a:solidFill>
+                  <a:srgbClr val="E08E2B"/>
+                </a:solidFill>
+                <a:latin typeface="Consolas"/>
+              </a:rPr>
+              <a:t>EBITDA</a:t>
+            </a:r>
+            <a:r>
+              <a:rPr sz="1450" b="1">
+                <a:solidFill>
+                  <a:srgbClr val="0F2A4A"/>
+                </a:solidFill>
+                <a:latin typeface="Georgia"/>
+              </a:rPr>
+              <a:t>   Earnings Before Interest, Tax, Depreciation &amp; Amortisation</a:t>
+            </a:r>
+          </a:p>
+          <a:p>
+            <a:pPr>
+              <a:spcBef>
+                <a:spcPts val="100"/>
+              </a:spcBef>
+            </a:pPr>
+            <a:r>
+              <a:rPr sz="1300">
+                <a:solidFill>
+                  <a:srgbClr val="4C5D6D"/>
+                </a:solidFill>
+                <a:latin typeface="Calibri"/>
+              </a:rPr>
+              <a:t>A common proxy for operating cash earnings.</a:t>
+            </a:r>
+          </a:p>
+          <a:p>
+            <a:pPr>
+              <a:spcBef>
+                <a:spcPts val="1100"/>
+              </a:spcBef>
+            </a:pPr>
+            <a:r>
+              <a:rPr sz="1500" b="1">
+                <a:solidFill>
+                  <a:srgbClr val="E08E2B"/>
+                </a:solidFill>
+                <a:latin typeface="Consolas"/>
+              </a:rPr>
+              <a:t>P/E</a:t>
+            </a:r>
+            <a:r>
+              <a:rPr sz="1450" b="1">
+                <a:solidFill>
+                  <a:srgbClr val="0F2A4A"/>
+                </a:solidFill>
+                <a:latin typeface="Georgia"/>
+              </a:rPr>
+              <a:t>   Price-to-Earnings ratio</a:t>
+            </a:r>
+          </a:p>
+          <a:p>
+            <a:pPr>
+              <a:spcBef>
+                <a:spcPts val="100"/>
+              </a:spcBef>
+            </a:pPr>
+            <a:r>
+              <a:rPr sz="1300">
+                <a:solidFill>
+                  <a:srgbClr val="4C5D6D"/>
+                </a:solidFill>
+                <a:latin typeface="Calibri"/>
+              </a:rPr>
+              <a:t>Share price divided by earnings per share.</a:t>
+            </a:r>
+          </a:p>
+          <a:p>
+            <a:pPr>
+              <a:spcBef>
+                <a:spcPts val="1100"/>
+              </a:spcBef>
+            </a:pPr>
+            <a:r>
+              <a:rPr sz="1500" b="1">
+                <a:solidFill>
+                  <a:srgbClr val="E08E2B"/>
+                </a:solidFill>
+                <a:latin typeface="Consolas"/>
+              </a:rPr>
+              <a:t>VC</a:t>
+            </a:r>
+            <a:r>
+              <a:rPr sz="1450" b="1">
+                <a:solidFill>
+                  <a:srgbClr val="0F2A4A"/>
+                </a:solidFill>
+                <a:latin typeface="Georgia"/>
+              </a:rPr>
+              <a:t>   Venture Capital</a:t>
+            </a:r>
+          </a:p>
+          <a:p>
+            <a:pPr>
+              <a:spcBef>
+                <a:spcPts val="100"/>
+              </a:spcBef>
+            </a:pPr>
+            <a:r>
+              <a:rPr sz="1300">
+                <a:solidFill>
+                  <a:srgbClr val="4C5D6D"/>
+                </a:solidFill>
+                <a:latin typeface="Calibri"/>
+              </a:rPr>
+              <a:t>The ‘VC method’ values a venture back from its target exit.</a:t>
+            </a:r>
+          </a:p>
+          <a:p>
+            <a:pPr>
+              <a:spcBef>
+                <a:spcPts val="1100"/>
+              </a:spcBef>
+            </a:pPr>
+            <a:r>
+              <a:rPr sz="1500" b="1">
+                <a:solidFill>
+                  <a:srgbClr val="E08E2B"/>
+                </a:solidFill>
+                <a:latin typeface="Consolas"/>
+              </a:rPr>
+              <a:t>E[V]</a:t>
+            </a:r>
+            <a:r>
+              <a:rPr sz="1450" b="1">
+                <a:solidFill>
+                  <a:srgbClr val="0F2A4A"/>
+                </a:solidFill>
+                <a:latin typeface="Georgia"/>
+              </a:rPr>
+              <a:t>   Expected Value</a:t>
+            </a:r>
+          </a:p>
+          <a:p>
+            <a:pPr>
+              <a:spcBef>
+                <a:spcPts val="100"/>
+              </a:spcBef>
+            </a:pPr>
+            <a:r>
+              <a:rPr sz="1300">
+                <a:solidFill>
+                  <a:srgbClr val="4C5D6D"/>
+                </a:solidFill>
+                <a:latin typeface="Calibri"/>
+              </a:rPr>
+              <a:t>Probability-weighted average across the scenarios.</a:t>
+            </a:r>
+          </a:p>
+        </p:txBody>
+      </p:sp>
+      <p:sp>
+        <p:nvSpPr>
+          <p:cNvPr id="11" name="TextBox 10"/>
+          <p:cNvSpPr txBox="1"/>
+          <p:nvPr/>
+        </p:nvSpPr>
+        <p:spPr>
+          <a:xfrm>
+            <a:off x="502920" y="6473952"/>
+            <a:ext cx="8686800" cy="274320"/>
+          </a:xfrm>
+          <a:prstGeom prst="rect">
+            <a:avLst/>
+          </a:prstGeom>
+          <a:noFill/>
+        </p:spPr>
+        <p:txBody>
+          <a:bodyPr wrap="square" lIns="18288" rIns="18288" tIns="18288" bIns="18288" anchor="t">
+            <a:spAutoFit/>
+          </a:bodyPr>
+          <a:lstStyle/>
+          <a:p>
+            <a:pPr algn="l">
+              <a:spcBef>
+                <a:spcPts val="0"/>
+              </a:spcBef>
+              <a:spcAft>
+                <a:spcPts val="0"/>
+              </a:spcAft>
+            </a:pPr>
+            <a:r>
+              <a:rPr sz="900" b="0" i="0">
+                <a:solidFill>
+                  <a:srgbClr val="4C5D6D"/>
+                </a:solidFill>
+                <a:latin typeface="Calibri"/>
+              </a:rPr>
+              <a:t>Valuing Deep-Tech Ventures  ·  Deep-Tech Lab (DTL) Training</a:t>
+            </a:r>
+          </a:p>
+        </p:txBody>
+      </p:sp>
+      <p:sp>
+        <p:nvSpPr>
+          <p:cNvPr id="12" name="TextBox 11"/>
+          <p:cNvSpPr txBox="1"/>
+          <p:nvPr/>
+        </p:nvSpPr>
+        <p:spPr>
+          <a:xfrm>
+            <a:off x="10972800" y="6400800"/>
+            <a:ext cx="731520" cy="365760"/>
+          </a:xfrm>
+          <a:prstGeom prst="rect">
+            <a:avLst/>
+          </a:prstGeom>
+          <a:noFill/>
+        </p:spPr>
+        <p:txBody>
+          <a:bodyPr wrap="square" lIns="18288" rIns="18288" tIns="18288" bIns="18288" anchor="t">
+            <a:spAutoFit/>
+          </a:bodyPr>
+          <a:lstStyle/>
+          <a:p>
+            <a:pPr algn="r">
+              <a:spcBef>
+                <a:spcPts val="0"/>
+              </a:spcBef>
+              <a:spcAft>
+                <a:spcPts val="0"/>
+              </a:spcAft>
+            </a:pPr>
+            <a:r>
+              <a:rPr sz="1250" b="1" i="0">
+                <a:solidFill>
+                  <a:srgbClr val="0F2A4A"/>
+                </a:solidFill>
+                <a:latin typeface="Georgia"/>
+              </a:rPr>
+              <a:t>42</a:t>
+            </a:r>
+          </a:p>
+        </p:txBody>
+      </p:sp>
+    </p:spTree>
+  </p:cSld>
+  <p:clrMapOvr>
+    <a:masterClrMapping/>
+  </p:clrMapOvr>
+</p:sld>
+</file>
+
+<file path=ppt/slides/slide43.xml><?xml version="1.0" encoding="utf-8"?>
+<p:sld xmlns:a="http://schemas.openxmlformats.org/drawingml/2006/main" xmlns:p="http://schemas.openxmlformats.org/presentationml/2006/main" xmlns:r="http://schemas.openxmlformats.org/officeDocument/2006/relationships">
+  <p:cSld>
+    <p:spTree>
+      <p:nvGrpSpPr>
+        <p:cNvPr id="1" name=""/>
+        <p:cNvGrpSpPr/>
+        <p:nvPr/>
+      </p:nvGrpSpPr>
+      <p:grpSpPr/>
+      <p:sp>
+        <p:nvSpPr>
+          <p:cNvPr id="2" name="Rectangle 1"/>
+          <p:cNvSpPr/>
+          <p:nvPr/>
+        </p:nvSpPr>
+        <p:spPr>
+          <a:xfrm>
+            <a:off x="0" y="0"/>
+            <a:ext cx="12191695" cy="969264"/>
+          </a:xfrm>
+          <a:prstGeom prst="rect">
+            <a:avLst/>
+          </a:prstGeom>
+          <a:solidFill>
+            <a:srgbClr val="0F2A4A"/>
+          </a:solidFill>
+          <a:ln>
+            <a:noFill/>
+          </a:ln>
+          <a:effectLst/>
+        </p:spPr>
+        <p:style>
+          <a:lnRef idx="1">
+            <a:schemeClr val="accent1"/>
+          </a:lnRef>
+          <a:fillRef idx="3">
+            <a:schemeClr val="accent1"/>
+          </a:fillRef>
+          <a:effectRef idx="2">
+            <a:schemeClr val="accent1"/>
+          </a:effectRef>
+          <a:fontRef idx="minor">
+            <a:schemeClr val="lt1"/>
+          </a:fontRef>
+        </p:style>
+        <p:txBody>
+          <a:bodyPr rtlCol="0" anchor="ctr"/>
+          <a:lstStyle/>
+          <a:p>
+            <a:pPr algn="ctr"/>
+          </a:p>
+        </p:txBody>
+      </p:sp>
+      <p:sp>
+        <p:nvSpPr>
+          <p:cNvPr id="3" name="Rectangle 2"/>
+          <p:cNvSpPr/>
+          <p:nvPr/>
+        </p:nvSpPr>
+        <p:spPr>
+          <a:xfrm>
+            <a:off x="0" y="969264"/>
+            <a:ext cx="12191695" cy="50292"/>
+          </a:xfrm>
+          <a:prstGeom prst="rect">
+            <a:avLst/>
+          </a:prstGeom>
+          <a:solidFill>
+            <a:srgbClr val="E08E2B"/>
+          </a:solidFill>
+          <a:ln>
+            <a:noFill/>
+          </a:ln>
+          <a:effectLst/>
+        </p:spPr>
+        <p:style>
+          <a:lnRef idx="1">
+            <a:schemeClr val="accent1"/>
+          </a:lnRef>
+          <a:fillRef idx="3">
+            <a:schemeClr val="accent1"/>
+          </a:fillRef>
+          <a:effectRef idx="2">
+            <a:schemeClr val="accent1"/>
+          </a:effectRef>
+          <a:fontRef idx="minor">
+            <a:schemeClr val="lt1"/>
+          </a:fontRef>
+        </p:style>
+        <p:txBody>
+          <a:bodyPr rtlCol="0" anchor="ctr"/>
+          <a:lstStyle/>
+          <a:p>
+            <a:pPr algn="ctr"/>
+          </a:p>
+        </p:txBody>
+      </p:sp>
+      <p:sp>
+        <p:nvSpPr>
+          <p:cNvPr id="4" name="TextBox 3"/>
+          <p:cNvSpPr txBox="1"/>
+          <p:nvPr/>
+        </p:nvSpPr>
+        <p:spPr>
+          <a:xfrm>
+            <a:off x="502920" y="118872"/>
+            <a:ext cx="10972800" cy="292608"/>
+          </a:xfrm>
+          <a:prstGeom prst="rect">
+            <a:avLst/>
+          </a:prstGeom>
+          <a:noFill/>
+        </p:spPr>
+        <p:txBody>
+          <a:bodyPr wrap="square" lIns="18288" rIns="18288" tIns="18288" bIns="18288" anchor="t">
+            <a:spAutoFit/>
+          </a:bodyPr>
+          <a:lstStyle/>
+          <a:p>
+            <a:pPr algn="l">
+              <a:spcBef>
+                <a:spcPts val="0"/>
+              </a:spcBef>
+              <a:spcAft>
+                <a:spcPts val="0"/>
+              </a:spcAft>
+            </a:pPr>
+            <a:r>
+              <a:rPr sz="1200" b="1" i="0">
+                <a:solidFill>
+                  <a:srgbClr val="E08E2B"/>
+                </a:solidFill>
+                <a:latin typeface="Calibri"/>
+              </a:rPr>
+              <a:t>APPENDIX  ·  GLOSSARY</a:t>
+            </a:r>
+          </a:p>
+        </p:txBody>
+      </p:sp>
+      <p:sp>
+        <p:nvSpPr>
+          <p:cNvPr id="5" name="TextBox 4"/>
+          <p:cNvSpPr txBox="1"/>
+          <p:nvPr/>
+        </p:nvSpPr>
+        <p:spPr>
+          <a:xfrm>
+            <a:off x="502920" y="365760"/>
+            <a:ext cx="11201400" cy="585216"/>
+          </a:xfrm>
+          <a:prstGeom prst="rect">
+            <a:avLst/>
+          </a:prstGeom>
+          <a:noFill/>
+        </p:spPr>
+        <p:txBody>
+          <a:bodyPr wrap="square" lIns="18288" rIns="18288" tIns="18288" bIns="18288" anchor="t">
+            <a:spAutoFit/>
+          </a:bodyPr>
+          <a:lstStyle/>
+          <a:p>
+            <a:pPr algn="l">
+              <a:spcBef>
+                <a:spcPts val="0"/>
+              </a:spcBef>
+              <a:spcAft>
+                <a:spcPts val="0"/>
+              </a:spcAft>
+            </a:pPr>
+            <a:r>
+              <a:rPr sz="2500" b="1" i="0">
+                <a:solidFill>
+                  <a:srgbClr val="FFFFFF"/>
+                </a:solidFill>
+                <a:latin typeface="Georgia"/>
+              </a:rPr>
+              <a:t>Abbreviations in full — market, science &amp; deal</a:t>
+            </a:r>
+          </a:p>
+        </p:txBody>
+      </p:sp>
+      <p:sp>
+        <p:nvSpPr>
+          <p:cNvPr id="6" name="TextBox 5"/>
+          <p:cNvSpPr txBox="1"/>
+          <p:nvPr/>
+        </p:nvSpPr>
+        <p:spPr>
+          <a:xfrm>
+            <a:off x="566928" y="1133856"/>
+            <a:ext cx="11064240" cy="457200"/>
+          </a:xfrm>
+          <a:prstGeom prst="rect">
+            <a:avLst/>
+          </a:prstGeom>
+          <a:noFill/>
+        </p:spPr>
+        <p:txBody>
+          <a:bodyPr wrap="square" lIns="18288" rIns="18288" tIns="18288" bIns="18288" anchor="t">
+            <a:spAutoFit/>
+          </a:bodyPr>
+          <a:lstStyle/>
+          <a:p>
+            <a:pPr algn="l">
+              <a:spcBef>
+                <a:spcPts val="0"/>
+              </a:spcBef>
+              <a:spcAft>
+                <a:spcPts val="0"/>
+              </a:spcAft>
+            </a:pPr>
+            <a:r>
+              <a:rPr sz="1400" b="0" i="1">
+                <a:solidFill>
+                  <a:srgbClr val="4C5D6D"/>
+                </a:solidFill>
+                <a:latin typeface="Calibri"/>
+              </a:rPr>
+              <a:t>Continued — market-sizing, scientific, regulatory and programme terms.</a:t>
+            </a:r>
+          </a:p>
+        </p:txBody>
+      </p:sp>
+      <p:sp>
+        <p:nvSpPr>
+          <p:cNvPr id="7" name="Rectangle 6"/>
+          <p:cNvSpPr/>
+          <p:nvPr/>
+        </p:nvSpPr>
+        <p:spPr>
+          <a:xfrm>
+            <a:off x="603504" y="1719072"/>
+            <a:ext cx="82296" cy="4160520"/>
+          </a:xfrm>
+          <a:prstGeom prst="rect">
+            <a:avLst/>
+          </a:prstGeom>
+          <a:solidFill>
+            <a:srgbClr val="E08E2B"/>
+          </a:solidFill>
+          <a:ln>
+            <a:noFill/>
+          </a:ln>
+          <a:effectLst/>
+        </p:spPr>
+        <p:style>
+          <a:lnRef idx="1">
+            <a:schemeClr val="accent1"/>
+          </a:lnRef>
+          <a:fillRef idx="3">
+            <a:schemeClr val="accent1"/>
+          </a:fillRef>
+          <a:effectRef idx="2">
+            <a:schemeClr val="accent1"/>
+          </a:effectRef>
+          <a:fontRef idx="minor">
+            <a:schemeClr val="lt1"/>
+          </a:fontRef>
+        </p:style>
+        <p:txBody>
+          <a:bodyPr rtlCol="0" anchor="ctr"/>
+          <a:lstStyle/>
+          <a:p>
+            <a:pPr algn="ctr"/>
+          </a:p>
+        </p:txBody>
+      </p:sp>
+      <p:sp>
+        <p:nvSpPr>
+          <p:cNvPr id="8" name="TextBox 7"/>
+          <p:cNvSpPr txBox="1"/>
+          <p:nvPr/>
+        </p:nvSpPr>
+        <p:spPr>
+          <a:xfrm>
+            <a:off x="841248" y="1645920"/>
+            <a:ext cx="5138928" cy="4526280"/>
+          </a:xfrm>
+          <a:prstGeom prst="rect">
+            <a:avLst/>
+          </a:prstGeom>
+          <a:noFill/>
+        </p:spPr>
+        <p:txBody>
+          <a:bodyPr wrap="square">
+            <a:spAutoFit/>
+          </a:bodyPr>
+          <a:lstStyle/>
+          <a:p>
+            <a:pPr>
+              <a:spcBef>
+                <a:spcPts val="0"/>
+              </a:spcBef>
+            </a:pPr>
+            <a:r>
+              <a:rPr sz="1500" b="1">
+                <a:solidFill>
+                  <a:srgbClr val="E08E2B"/>
+                </a:solidFill>
+                <a:latin typeface="Consolas"/>
+              </a:rPr>
+              <a:t>DTL</a:t>
+            </a:r>
+            <a:r>
+              <a:rPr sz="1450" b="1">
+                <a:solidFill>
+                  <a:srgbClr val="0F2A4A"/>
+                </a:solidFill>
+                <a:latin typeface="Georgia"/>
+              </a:rPr>
+              <a:t>   Deep-Tech Lab</a:t>
+            </a:r>
+          </a:p>
+          <a:p>
+            <a:pPr>
+              <a:spcBef>
+                <a:spcPts val="100"/>
+              </a:spcBef>
+            </a:pPr>
+            <a:r>
+              <a:rPr sz="1300">
+                <a:solidFill>
+                  <a:srgbClr val="4C5D6D"/>
+                </a:solidFill>
+                <a:latin typeface="Calibri"/>
+              </a:rPr>
+              <a:t>The venture-development programme this training supports.</a:t>
+            </a:r>
+          </a:p>
+          <a:p>
+            <a:pPr>
+              <a:spcBef>
+                <a:spcPts val="1100"/>
+              </a:spcBef>
+            </a:pPr>
+            <a:r>
+              <a:rPr sz="1500" b="1">
+                <a:solidFill>
+                  <a:srgbClr val="E08E2B"/>
+                </a:solidFill>
+                <a:latin typeface="Consolas"/>
+              </a:rPr>
+              <a:t>IP</a:t>
+            </a:r>
+            <a:r>
+              <a:rPr sz="1450" b="1">
+                <a:solidFill>
+                  <a:srgbClr val="0F2A4A"/>
+                </a:solidFill>
+                <a:latin typeface="Georgia"/>
+              </a:rPr>
+              <a:t>   Intellectual Property</a:t>
+            </a:r>
+          </a:p>
+          <a:p>
+            <a:pPr>
+              <a:spcBef>
+                <a:spcPts val="100"/>
+              </a:spcBef>
+            </a:pPr>
+            <a:r>
+              <a:rPr sz="1300">
+                <a:solidFill>
+                  <a:srgbClr val="4C5D6D"/>
+                </a:solidFill>
+                <a:latin typeface="Calibri"/>
+              </a:rPr>
+              <a:t>Patents, know-how and freedom-to-operate position.</a:t>
+            </a:r>
+          </a:p>
+          <a:p>
+            <a:pPr>
+              <a:spcBef>
+                <a:spcPts val="1100"/>
+              </a:spcBef>
+            </a:pPr>
+            <a:r>
+              <a:rPr sz="1500" b="1">
+                <a:solidFill>
+                  <a:srgbClr val="E08E2B"/>
+                </a:solidFill>
+                <a:latin typeface="Consolas"/>
+              </a:rPr>
+              <a:t>R&amp;D</a:t>
+            </a:r>
+            <a:r>
+              <a:rPr sz="1450" b="1">
+                <a:solidFill>
+                  <a:srgbClr val="0F2A4A"/>
+                </a:solidFill>
+                <a:latin typeface="Georgia"/>
+              </a:rPr>
+              <a:t>   Research and Development</a:t>
+            </a:r>
+          </a:p>
+          <a:p>
+            <a:pPr>
+              <a:spcBef>
+                <a:spcPts val="100"/>
+              </a:spcBef>
+            </a:pPr>
+            <a:r>
+              <a:rPr sz="1300">
+                <a:solidFill>
+                  <a:srgbClr val="4C5D6D"/>
+                </a:solidFill>
+                <a:latin typeface="Calibri"/>
+              </a:rPr>
+              <a:t>The core scientific and engineering work of the venture.</a:t>
+            </a:r>
+          </a:p>
+          <a:p>
+            <a:pPr>
+              <a:spcBef>
+                <a:spcPts val="1100"/>
+              </a:spcBef>
+            </a:pPr>
+            <a:r>
+              <a:rPr sz="1500" b="1">
+                <a:solidFill>
+                  <a:srgbClr val="E08E2B"/>
+                </a:solidFill>
+                <a:latin typeface="Consolas"/>
+              </a:rPr>
+              <a:t>TAM</a:t>
+            </a:r>
+            <a:r>
+              <a:rPr sz="1450" b="1">
+                <a:solidFill>
+                  <a:srgbClr val="0F2A4A"/>
+                </a:solidFill>
+                <a:latin typeface="Georgia"/>
+              </a:rPr>
+              <a:t>   Total Addressable Market</a:t>
+            </a:r>
+          </a:p>
+          <a:p>
+            <a:pPr>
+              <a:spcBef>
+                <a:spcPts val="100"/>
+              </a:spcBef>
+            </a:pPr>
+            <a:r>
+              <a:rPr sz="1300">
+                <a:solidFill>
+                  <a:srgbClr val="4C5D6D"/>
+                </a:solidFill>
+                <a:latin typeface="Calibri"/>
+              </a:rPr>
+              <a:t>Total demand if the product reached every possible user.</a:t>
+            </a:r>
+          </a:p>
+          <a:p>
+            <a:pPr>
+              <a:spcBef>
+                <a:spcPts val="1100"/>
+              </a:spcBef>
+            </a:pPr>
+            <a:r>
+              <a:rPr sz="1500" b="1">
+                <a:solidFill>
+                  <a:srgbClr val="E08E2B"/>
+                </a:solidFill>
+                <a:latin typeface="Consolas"/>
+              </a:rPr>
+              <a:t>SAM</a:t>
+            </a:r>
+            <a:r>
+              <a:rPr sz="1450" b="1">
+                <a:solidFill>
+                  <a:srgbClr val="0F2A4A"/>
+                </a:solidFill>
+                <a:latin typeface="Georgia"/>
+              </a:rPr>
+              <a:t>   Serviceable Available Market</a:t>
+            </a:r>
+          </a:p>
+          <a:p>
+            <a:pPr>
+              <a:spcBef>
+                <a:spcPts val="100"/>
+              </a:spcBef>
+            </a:pPr>
+            <a:r>
+              <a:rPr sz="1300">
+                <a:solidFill>
+                  <a:srgbClr val="4C5D6D"/>
+                </a:solidFill>
+                <a:latin typeface="Calibri"/>
+              </a:rPr>
+              <a:t>The slice the product and channel can realistically serve.</a:t>
+            </a:r>
+          </a:p>
+          <a:p>
+            <a:pPr>
+              <a:spcBef>
+                <a:spcPts val="1100"/>
+              </a:spcBef>
+            </a:pPr>
+            <a:r>
+              <a:rPr sz="1500" b="1">
+                <a:solidFill>
+                  <a:srgbClr val="E08E2B"/>
+                </a:solidFill>
+                <a:latin typeface="Consolas"/>
+              </a:rPr>
+              <a:t>SOM</a:t>
+            </a:r>
+            <a:r>
+              <a:rPr sz="1450" b="1">
+                <a:solidFill>
+                  <a:srgbClr val="0F2A4A"/>
+                </a:solidFill>
+                <a:latin typeface="Georgia"/>
+              </a:rPr>
+              <a:t>   Serviceable Obtainable Market</a:t>
+            </a:r>
+          </a:p>
+          <a:p>
+            <a:pPr>
+              <a:spcBef>
+                <a:spcPts val="100"/>
+              </a:spcBef>
+            </a:pPr>
+            <a:r>
+              <a:rPr sz="1300">
+                <a:solidFill>
+                  <a:srgbClr val="4C5D6D"/>
+                </a:solidFill>
+                <a:latin typeface="Calibri"/>
+              </a:rPr>
+              <a:t>The market share the venture can actually win near-term.</a:t>
+            </a:r>
+          </a:p>
+          <a:p>
+            <a:pPr>
+              <a:spcBef>
+                <a:spcPts val="1100"/>
+              </a:spcBef>
+            </a:pPr>
+            <a:r>
+              <a:rPr sz="1500" b="1">
+                <a:solidFill>
+                  <a:srgbClr val="E08E2B"/>
+                </a:solidFill>
+                <a:latin typeface="Consolas"/>
+              </a:rPr>
+              <a:t>CAGR</a:t>
+            </a:r>
+            <a:r>
+              <a:rPr sz="1450" b="1">
+                <a:solidFill>
+                  <a:srgbClr val="0F2A4A"/>
+                </a:solidFill>
+                <a:latin typeface="Georgia"/>
+              </a:rPr>
+              <a:t>   Compound Annual Growth Rate</a:t>
+            </a:r>
+          </a:p>
+          <a:p>
+            <a:pPr>
+              <a:spcBef>
+                <a:spcPts val="100"/>
+              </a:spcBef>
+            </a:pPr>
+            <a:r>
+              <a:rPr sz="1300">
+                <a:solidFill>
+                  <a:srgbClr val="4C5D6D"/>
+                </a:solidFill>
+                <a:latin typeface="Calibri"/>
+              </a:rPr>
+              <a:t>Smoothed year-on-year growth rate over a period.</a:t>
+            </a:r>
+          </a:p>
+        </p:txBody>
+      </p:sp>
+      <p:sp>
+        <p:nvSpPr>
+          <p:cNvPr id="9" name="Rectangle 8"/>
+          <p:cNvSpPr/>
+          <p:nvPr/>
+        </p:nvSpPr>
+        <p:spPr>
+          <a:xfrm>
+            <a:off x="6254496" y="1719072"/>
+            <a:ext cx="82296" cy="4160520"/>
+          </a:xfrm>
+          <a:prstGeom prst="rect">
+            <a:avLst/>
+          </a:prstGeom>
+          <a:solidFill>
+            <a:srgbClr val="E08E2B"/>
+          </a:solidFill>
+          <a:ln>
+            <a:noFill/>
+          </a:ln>
+          <a:effectLst/>
+        </p:spPr>
+        <p:style>
+          <a:lnRef idx="1">
+            <a:schemeClr val="accent1"/>
+          </a:lnRef>
+          <a:fillRef idx="3">
+            <a:schemeClr val="accent1"/>
+          </a:fillRef>
+          <a:effectRef idx="2">
+            <a:schemeClr val="accent1"/>
+          </a:effectRef>
+          <a:fontRef idx="minor">
+            <a:schemeClr val="lt1"/>
+          </a:fontRef>
+        </p:style>
+        <p:txBody>
+          <a:bodyPr rtlCol="0" anchor="ctr"/>
+          <a:lstStyle/>
+          <a:p>
+            <a:pPr algn="ctr"/>
+          </a:p>
+        </p:txBody>
+      </p:sp>
+      <p:sp>
+        <p:nvSpPr>
+          <p:cNvPr id="10" name="TextBox 9"/>
+          <p:cNvSpPr txBox="1"/>
+          <p:nvPr/>
+        </p:nvSpPr>
+        <p:spPr>
+          <a:xfrm>
+            <a:off x="6492240" y="1645920"/>
+            <a:ext cx="5138928" cy="4526280"/>
+          </a:xfrm>
+          <a:prstGeom prst="rect">
+            <a:avLst/>
+          </a:prstGeom>
+          <a:noFill/>
+        </p:spPr>
+        <p:txBody>
+          <a:bodyPr wrap="square">
+            <a:spAutoFit/>
+          </a:bodyPr>
+          <a:lstStyle/>
+          <a:p>
+            <a:pPr>
+              <a:spcBef>
+                <a:spcPts val="0"/>
+              </a:spcBef>
+            </a:pPr>
+            <a:r>
+              <a:rPr sz="1500" b="1">
+                <a:solidFill>
+                  <a:srgbClr val="E08E2B"/>
+                </a:solidFill>
+                <a:latin typeface="Consolas"/>
+              </a:rPr>
+              <a:t>GTM</a:t>
+            </a:r>
+            <a:r>
+              <a:rPr sz="1450" b="1">
+                <a:solidFill>
+                  <a:srgbClr val="0F2A4A"/>
+                </a:solidFill>
+                <a:latin typeface="Georgia"/>
+              </a:rPr>
+              <a:t>   Go-To-Market</a:t>
+            </a:r>
+          </a:p>
+          <a:p>
+            <a:pPr>
+              <a:spcBef>
+                <a:spcPts val="100"/>
+              </a:spcBef>
+            </a:pPr>
+            <a:r>
+              <a:rPr sz="1300">
+                <a:solidFill>
+                  <a:srgbClr val="4C5D6D"/>
+                </a:solidFill>
+                <a:latin typeface="Calibri"/>
+              </a:rPr>
+              <a:t>Commercial launch — first sales and channel activity.</a:t>
+            </a:r>
+          </a:p>
+          <a:p>
+            <a:pPr>
+              <a:spcBef>
+                <a:spcPts val="1100"/>
+              </a:spcBef>
+            </a:pPr>
+            <a:r>
+              <a:rPr sz="1500" b="1">
+                <a:solidFill>
+                  <a:srgbClr val="E08E2B"/>
+                </a:solidFill>
+                <a:latin typeface="Consolas"/>
+              </a:rPr>
+              <a:t>FDA</a:t>
+            </a:r>
+            <a:r>
+              <a:rPr sz="1450" b="1">
+                <a:solidFill>
+                  <a:srgbClr val="0F2A4A"/>
+                </a:solidFill>
+                <a:latin typeface="Georgia"/>
+              </a:rPr>
+              <a:t>   US Food and Drug Administration</a:t>
+            </a:r>
+          </a:p>
+          <a:p>
+            <a:pPr>
+              <a:spcBef>
+                <a:spcPts val="100"/>
+              </a:spcBef>
+            </a:pPr>
+            <a:r>
+              <a:rPr sz="1300">
+                <a:solidFill>
+                  <a:srgbClr val="4C5D6D"/>
+                </a:solidFill>
+                <a:latin typeface="Calibri"/>
+              </a:rPr>
+              <a:t>The United States medical-products regulator.</a:t>
+            </a:r>
+          </a:p>
+          <a:p>
+            <a:pPr>
+              <a:spcBef>
+                <a:spcPts val="1100"/>
+              </a:spcBef>
+            </a:pPr>
+            <a:r>
+              <a:rPr sz="1500" b="1">
+                <a:solidFill>
+                  <a:srgbClr val="E08E2B"/>
+                </a:solidFill>
+                <a:latin typeface="Consolas"/>
+              </a:rPr>
+              <a:t>510(k)</a:t>
+            </a:r>
+            <a:r>
+              <a:rPr sz="1450" b="1">
+                <a:solidFill>
+                  <a:srgbClr val="0F2A4A"/>
+                </a:solidFill>
+                <a:latin typeface="Georgia"/>
+              </a:rPr>
+              <a:t>   FDA Premarket Notification</a:t>
+            </a:r>
+          </a:p>
+          <a:p>
+            <a:pPr>
+              <a:spcBef>
+                <a:spcPts val="100"/>
+              </a:spcBef>
+            </a:pPr>
+            <a:r>
+              <a:rPr sz="1300">
+                <a:solidFill>
+                  <a:srgbClr val="4C5D6D"/>
+                </a:solidFill>
+                <a:latin typeface="Calibri"/>
+              </a:rPr>
+              <a:t>Clearance route for many Class II medical devices.</a:t>
+            </a:r>
+          </a:p>
+          <a:p>
+            <a:pPr>
+              <a:spcBef>
+                <a:spcPts val="1100"/>
+              </a:spcBef>
+            </a:pPr>
+            <a:r>
+              <a:rPr sz="1500" b="1">
+                <a:solidFill>
+                  <a:srgbClr val="E08E2B"/>
+                </a:solidFill>
+                <a:latin typeface="Consolas"/>
+              </a:rPr>
+              <a:t>MRI</a:t>
+            </a:r>
+            <a:r>
+              <a:rPr sz="1450" b="1">
+                <a:solidFill>
+                  <a:srgbClr val="0F2A4A"/>
+                </a:solidFill>
+                <a:latin typeface="Georgia"/>
+              </a:rPr>
+              <a:t>   Magnetic Resonance Imaging</a:t>
+            </a:r>
+          </a:p>
+          <a:p>
+            <a:pPr>
+              <a:spcBef>
+                <a:spcPts val="100"/>
+              </a:spcBef>
+            </a:pPr>
+            <a:r>
+              <a:rPr sz="1300">
+                <a:solidFill>
+                  <a:srgbClr val="4C5D6D"/>
+                </a:solidFill>
+                <a:latin typeface="Calibri"/>
+              </a:rPr>
+              <a:t>Imaging used by the diagnostic-venture worked example.</a:t>
+            </a:r>
+          </a:p>
+          <a:p>
+            <a:pPr>
+              <a:spcBef>
+                <a:spcPts val="1100"/>
+              </a:spcBef>
+            </a:pPr>
+            <a:r>
+              <a:rPr sz="1500" b="1">
+                <a:solidFill>
+                  <a:srgbClr val="E08E2B"/>
+                </a:solidFill>
+                <a:latin typeface="Consolas"/>
+              </a:rPr>
+              <a:t>WBI</a:t>
+            </a:r>
+            <a:r>
+              <a:rPr sz="1450" b="1">
+                <a:solidFill>
+                  <a:srgbClr val="0F2A4A"/>
+                </a:solidFill>
+                <a:latin typeface="Georgia"/>
+              </a:rPr>
+              <a:t>   Wellbiz International</a:t>
+            </a:r>
+          </a:p>
+          <a:p>
+            <a:pPr>
+              <a:spcBef>
+                <a:spcPts val="100"/>
+              </a:spcBef>
+            </a:pPr>
+            <a:r>
+              <a:rPr sz="1300">
+                <a:solidFill>
+                  <a:srgbClr val="4C5D6D"/>
+                </a:solidFill>
+                <a:latin typeface="Calibri"/>
+              </a:rPr>
+              <a:t>Real venture used in the valuation-comparison example.</a:t>
+            </a:r>
+          </a:p>
+          <a:p>
+            <a:pPr>
+              <a:spcBef>
+                <a:spcPts val="1100"/>
+              </a:spcBef>
+            </a:pPr>
+            <a:r>
+              <a:rPr sz="1500" b="1">
+                <a:solidFill>
+                  <a:srgbClr val="E08E2B"/>
+                </a:solidFill>
+                <a:latin typeface="Consolas"/>
+              </a:rPr>
+              <a:t>US$M</a:t>
+            </a:r>
+            <a:r>
+              <a:rPr sz="1450" b="1">
+                <a:solidFill>
+                  <a:srgbClr val="0F2A4A"/>
+                </a:solidFill>
+                <a:latin typeface="Georgia"/>
+              </a:rPr>
+              <a:t>   US dollars, millions</a:t>
+            </a:r>
+          </a:p>
+          <a:p>
+            <a:pPr>
+              <a:spcBef>
+                <a:spcPts val="100"/>
+              </a:spcBef>
+            </a:pPr>
+            <a:r>
+              <a:rPr sz="1300">
+                <a:solidFill>
+                  <a:srgbClr val="4C5D6D"/>
+                </a:solidFill>
+                <a:latin typeface="Calibri"/>
+              </a:rPr>
+              <a:t>Currency unit used throughout the worked examples.</a:t>
+            </a:r>
+          </a:p>
+        </p:txBody>
+      </p:sp>
+      <p:sp>
+        <p:nvSpPr>
+          <p:cNvPr id="11" name="TextBox 10"/>
+          <p:cNvSpPr txBox="1"/>
+          <p:nvPr/>
+        </p:nvSpPr>
+        <p:spPr>
+          <a:xfrm>
+            <a:off x="502920" y="6473952"/>
+            <a:ext cx="8686800" cy="274320"/>
+          </a:xfrm>
+          <a:prstGeom prst="rect">
+            <a:avLst/>
+          </a:prstGeom>
+          <a:noFill/>
+        </p:spPr>
+        <p:txBody>
+          <a:bodyPr wrap="square" lIns="18288" rIns="18288" tIns="18288" bIns="18288" anchor="t">
+            <a:spAutoFit/>
+          </a:bodyPr>
+          <a:lstStyle/>
+          <a:p>
+            <a:pPr algn="l">
+              <a:spcBef>
+                <a:spcPts val="0"/>
+              </a:spcBef>
+              <a:spcAft>
+                <a:spcPts val="0"/>
+              </a:spcAft>
+            </a:pPr>
+            <a:r>
+              <a:rPr sz="900" b="0" i="0">
+                <a:solidFill>
+                  <a:srgbClr val="4C5D6D"/>
+                </a:solidFill>
+                <a:latin typeface="Calibri"/>
+              </a:rPr>
+              <a:t>Valuing Deep-Tech Ventures  ·  Deep-Tech Lab (DTL) Training</a:t>
+            </a:r>
+          </a:p>
+        </p:txBody>
+      </p:sp>
+      <p:sp>
+        <p:nvSpPr>
+          <p:cNvPr id="12" name="TextBox 11"/>
+          <p:cNvSpPr txBox="1"/>
+          <p:nvPr/>
+        </p:nvSpPr>
+        <p:spPr>
+          <a:xfrm>
+            <a:off x="10972800" y="6400800"/>
+            <a:ext cx="731520" cy="365760"/>
+          </a:xfrm>
+          <a:prstGeom prst="rect">
+            <a:avLst/>
+          </a:prstGeom>
+          <a:noFill/>
+        </p:spPr>
+        <p:txBody>
+          <a:bodyPr wrap="square" lIns="18288" rIns="18288" tIns="18288" bIns="18288" anchor="t">
+            <a:spAutoFit/>
+          </a:bodyPr>
+          <a:lstStyle/>
+          <a:p>
+            <a:pPr algn="r">
+              <a:spcBef>
+                <a:spcPts val="0"/>
+              </a:spcBef>
+              <a:spcAft>
+                <a:spcPts val="0"/>
+              </a:spcAft>
+            </a:pPr>
+            <a:r>
+              <a:rPr sz="1250" b="1" i="0">
+                <a:solidFill>
+                  <a:srgbClr val="0F2A4A"/>
+                </a:solidFill>
+                <a:latin typeface="Georgia"/>
+              </a:rPr>
+              <a:t>43</a:t>
             </a:r>
           </a:p>
         </p:txBody>

</xml_diff>